<commit_message>
Briefing com nível de exposição, estilos de comunicação (4 cores), miniaturas renderizadas
- 00-guia/briefing.md: roteiro para descobrir mensagem central, objetivo e nível de exposição (interno / interáreas / externo); passo 0 em como-usar.md
- 02-publicos/estilos-de-comunicacao.md: Vermelho, Amarelo, Verde, Azul com regras de construção do deck e cruzamento nível × estilo
- 07-checklists/nivel-de-exposicao.md
- schema: meta.key_message, objective, communication_style, exposure
- render_thumbnails.py (PowerPoint COM) + examples/thumbnails com 123 PNGs
- deckbuilder: barras horizontais com 1ª categoria no topo, KPI com valor longo reduz fonte

Co-Authored-By: Claude Fable 5.1 <noreply@anthropic.com>
</commit_message>
<xml_diff>
--- a/examples/relatorio-de-vendas.pptx
+++ b/examples/relatorio-de-vendas.pptx
@@ -258,7 +258,7 @@
       <c:catAx>
         <c:axId val="-2068027336"/>
         <c:scaling>
-          <c:orientation val="minMax"/>
+          <c:orientation val="maxMin"/>
         </c:scaling>
         <c:delete val="0"/>
         <c:axPos val="l"/>
@@ -328,7 +328,7 @@
           </a:p>
         </c:txPr>
         <c:crossAx val="-2068027336"/>
-        <c:crosses val="autoZero"/>
+        <c:crosses val="max"/>
       </c:valAx>
     </c:plotArea>
     <c:legend>
@@ -469,7 +469,7 @@
       <c:catAx>
         <c:axId val="-2068027336"/>
         <c:scaling>
-          <c:orientation val="minMax"/>
+          <c:orientation val="maxMin"/>
         </c:scaling>
         <c:delete val="0"/>
         <c:axPos val="l"/>
@@ -539,7 +539,7 @@
           </a:p>
         </c:txPr>
         <c:crossAx val="-2068027336"/>
-        <c:crosses val="autoZero"/>
+        <c:crosses val="max"/>
       </c:valAx>
     </c:plotArea>
     <c:dispBlanksAs val="gap"/>
@@ -4473,7 +4473,7 @@
           <a:p>
             <a:pPr algn="l"/>
             <a:r>
-              <a:rPr sz="4000" b="1" i="0">
+              <a:rPr sz="3000" b="1" i="0">
                 <a:solidFill>
                   <a:srgbClr val="2D2D2D"/>
                 </a:solidFill>
@@ -4666,7 +4666,7 @@
           <a:p>
             <a:pPr algn="l"/>
             <a:r>
-              <a:rPr sz="4000" b="1" i="0">
+              <a:rPr sz="2500" b="1" i="0">
                 <a:solidFill>
                   <a:srgbClr val="2D2D2D"/>
                 </a:solidFill>

</xml_diff>